<commit_message>
docs: sync architecture docs for the translator service (8th service)
The translator service (port 8005, ontology-grounded NL->domain
translation) was added but the docs still described a 7-service system.

- SERVICES.md: add translator to the Service Map; new Translator
  section (endpoints, ontology Neo4j + Qdrant deps, fallback behavior);
  document the Financial Governance /v1/finops/* endpoints under the
  orchestrator.
- PMOS_Architecture_Presentation.pptx: C2 diagram now shows 8
  microservices with a Translator container box; tech-stack and
  closing slides updated (6 Python services, 8 containers).

Note: CLAUDE.md was also updated but lives above the pmos/ repo root
so it is not tracked here.

Co-Authored-By: Claude Opus 4.7 (1M context) <noreply@anthropic.com>
</commit_message>
<xml_diff>
--- a/docs/PMOS_Architecture_Presentation.pptx
+++ b/docs/PMOS_Architecture_Presentation.pptx
@@ -10943,7 +10943,7 @@
               </a:defRPr>
             </a:pPr>
             <a:r>
-              <a:t>7 microservices  |  4 data stores  |  6 agents  |  7 Redis streams</a:t>
+              <a:t>8 microservices  |  4 data stores  |  6 agents  |  7 Redis streams</a:t>
             </a:r>
             <a:br/>
             <a:br/>
@@ -14022,7 +14022,7 @@
               </a:defRPr>
             </a:pPr>
             <a:r>
-              <a:t>7 microservices + React frontend + 4 backing stores</a:t>
+              <a:t>8 microservices + React frontend + 4 backing stores</a:t>
             </a:r>
           </a:p>
         </p:txBody>
@@ -14150,7 +14150,7 @@
         <p:spPr>
           <a:xfrm>
             <a:off x="274320" y="2377440"/>
-            <a:ext cx="1828800" cy="914400"/>
+            <a:ext cx="1541160" cy="914400"/>
           </a:xfrm>
           <a:prstGeom prst="roundRect">
             <a:avLst/>
@@ -14208,14 +14208,79 @@
       </p:sp>
       <p:sp>
         <p:nvSpPr>
+          <p:cNvPr id="17" name="Rounded Rectangle Translator"/>
+          <p:cNvSpPr/>
+          <p:nvPr/>
+        </p:nvSpPr>
+        <p:spPr>
+          <a:xfrm>
+            <a:off x="10344240" y="2377440"/>
+            <a:ext cx="1541160" cy="914400"/>
+          </a:xfrm>
+          <a:prstGeom prst="roundRect">
+            <a:avLst/>
+          </a:prstGeom>
+          <a:solidFill>
+            <a:srgbClr val="007BFF"/>
+          </a:solidFill>
+          <a:ln>
+            <a:noFill/>
+          </a:ln>
+        </p:spPr>
+        <p:style>
+          <a:lnRef idx="1">
+            <a:schemeClr val="accent1"/>
+          </a:lnRef>
+          <a:fillRef idx="3">
+            <a:schemeClr val="accent1"/>
+          </a:fillRef>
+          <a:effectRef idx="2">
+            <a:schemeClr val="accent1"/>
+          </a:effectRef>
+          <a:fontRef idx="minor">
+            <a:schemeClr val="lt1"/>
+          </a:fontRef>
+        </p:style>
+        <p:txBody>
+          <a:bodyPr rtlCol="0" anchor="ctr" wrap="square"/>
+          <a:lstStyle/>
+          <a:p>
+            <a:pPr algn="ctr">
+              <a:defRPr sz="800" b="1">
+                <a:solidFill>
+                  <a:srgbClr val="FFFFFF"/>
+                </a:solidFill>
+                <a:latin typeface="Segoe UI"/>
+              </a:defRPr>
+            </a:pPr>
+            <a:r>
+              <a:t>Translator</a:t>
+            </a:r>
+            <a:br/>
+            <a:r>
+              <a:t>Port 8005</a:t>
+            </a:r>
+            <a:br/>
+            <a:r>
+              <a:t>FastAPI</a:t>
+            </a:r>
+            <a:br/>
+            <a:r>
+              <a:t>Ontology NL→Domain</a:t>
+            </a:r>
+          </a:p>
+        </p:txBody>
+      </p:sp>
+      <p:sp>
+        <p:nvSpPr>
           <p:cNvPr id="7" name="Rounded Rectangle 6"/>
           <p:cNvSpPr/>
           <p:nvPr/>
         </p:nvSpPr>
         <p:spPr>
           <a:xfrm>
-            <a:off x="2286000" y="2377440"/>
-            <a:ext cx="1828800" cy="914400"/>
+            <a:off x="1952640" y="2377440"/>
+            <a:ext cx="1541160" cy="914400"/>
           </a:xfrm>
           <a:prstGeom prst="roundRect">
             <a:avLst/>
@@ -14279,8 +14344,8 @@
         </p:nvSpPr>
         <p:spPr>
           <a:xfrm>
-            <a:off x="4297680" y="2377440"/>
-            <a:ext cx="1828800" cy="914400"/>
+            <a:off x="3630960" y="2377440"/>
+            <a:ext cx="1541160" cy="914400"/>
           </a:xfrm>
           <a:prstGeom prst="roundRect">
             <a:avLst/>
@@ -14344,8 +14409,8 @@
         </p:nvSpPr>
         <p:spPr>
           <a:xfrm>
-            <a:off x="6309360" y="2377440"/>
-            <a:ext cx="1828800" cy="914400"/>
+            <a:off x="5309280" y="2377440"/>
+            <a:ext cx="1541160" cy="914400"/>
           </a:xfrm>
           <a:prstGeom prst="roundRect">
             <a:avLst/>
@@ -14409,8 +14474,8 @@
         </p:nvSpPr>
         <p:spPr>
           <a:xfrm>
-            <a:off x="8321040" y="2377440"/>
-            <a:ext cx="1828800" cy="914400"/>
+            <a:off x="6987600" y="2377440"/>
+            <a:ext cx="1541160" cy="914400"/>
           </a:xfrm>
           <a:prstGeom prst="roundRect">
             <a:avLst/>
@@ -14474,8 +14539,8 @@
         </p:nvSpPr>
         <p:spPr>
           <a:xfrm>
-            <a:off x="10332720" y="2377440"/>
-            <a:ext cx="1554480" cy="914400"/>
+            <a:off x="8665920" y="2377440"/>
+            <a:ext cx="1541160" cy="914400"/>
           </a:xfrm>
           <a:prstGeom prst="roundRect">
             <a:avLst/>
@@ -14814,7 +14879,7 @@
             </a:r>
             <a:br/>
             <a:r>
-              <a:t>Pipeline: Decompose → Negotiate (agents bid) → Execute (tool-use loop + sub-agents) → Score → Aggregate → Learn</a:t>
+              <a:t>Pipeline: Translate (ontology) → Decompose → Negotiate (agents bid) → Execute (tool-use loop + sub-agents) → Score → Aggregate → Sufficiency loop → Learn</a:t>
             </a:r>
             <a:br/>
             <a:r>
@@ -19741,7 +19806,7 @@
             </a:r>
             <a:br/>
             <a:r>
-              <a:t>15 pages: Chat, Agent Studio, Monitors</a:t>
+              <a:t>16 pages: Chat, Studio, Monitors, Financial Governance</a:t>
             </a:r>
           </a:p>
         </p:txBody>
@@ -19912,7 +19977,7 @@
             <a:br/>
             <a:br/>
             <a:r>
-              <a:t>5 Python (FastAPI 0.109)</a:t>
+              <a:t>6 Python (FastAPI 0.109)</a:t>
             </a:r>
             <a:br/>
             <a:r>
@@ -19920,7 +19985,7 @@
             </a:r>
             <a:br/>
             <a:r>
-              <a:t>    Scoring, Meta-Assembly</a:t>
+              <a:t>    Scoring, Meta-Assembly, Translator</a:t>
             </a:r>
             <a:br/>
             <a:r>
@@ -20638,7 +20703,7 @@
               </a:defRPr>
             </a:pPr>
             <a:r>
-              <a:t>Docker Compose — 7 containers</a:t>
+              <a:t>Docker Compose — 8 containers</a:t>
             </a:r>
             <a:br/>
             <a:r>

</xml_diff>